<commit_message>
C6+ U0 PowerPoint: volledig paars (groen+teal weggewerkt via nabewerking), footer 'C5·A1'->'C6+', echte LPD-codes in docentnotitie
</commit_message>
<xml_diff>
--- a/03-build/pptx/C6plus_U0_alumno.pptx
+++ b/03-build/pptx/C6plus_U0_alumno.pptx
@@ -4180,7 +4180,7 @@
                 </a:solidFill>
                 <a:latin typeface="Inter"/>
               </a:rPr>
-              <a:t>U0 · ¡VOLVEMOS!   ·   C5 · A1 · La Ruta</a:t>
+              <a:t>U0 · ¡VOLVEMOS!   ·   C6+ · el reencuentro</a:t>
             </a:r>
           </a:p>
         </p:txBody>
@@ -4352,7 +4352,7 @@
             <a:avLst/>
           </a:prstGeom>
           <a:solidFill>
-            <a:srgbClr val="1E9E74"/>
+            <a:srgbClr val="7C56A9"/>
           </a:solidFill>
           <a:ln>
             <a:noFill/>
@@ -4471,7 +4471,7 @@
             <a:r>
               <a:rPr sz="1100" b="1">
                 <a:solidFill>
-                  <a:srgbClr val="1E9E74"/>
+                  <a:srgbClr val="7C56A9"/>
                 </a:solidFill>
                 <a:latin typeface="Inter"/>
               </a:rPr>
@@ -6375,7 +6375,7 @@
                 </a:solidFill>
                 <a:latin typeface="Inter"/>
               </a:rPr>
-              <a:t>U0 · ¡VOLVEMOS!   ·   C5 · A1 · La Ruta</a:t>
+              <a:t>U0 · ¡VOLVEMOS!   ·   C6+ · el reencuentro</a:t>
             </a:r>
           </a:p>
         </p:txBody>
@@ -7107,7 +7107,7 @@
             <a:avLst/>
           </a:prstGeom>
           <a:solidFill>
-            <a:srgbClr val="1E9E74"/>
+            <a:srgbClr val="7C56A9"/>
           </a:solidFill>
           <a:ln>
             <a:noFill/>
@@ -7226,7 +7226,7 @@
             <a:r>
               <a:rPr sz="1100" b="1">
                 <a:solidFill>
-                  <a:srgbClr val="1E9E74"/>
+                  <a:srgbClr val="7C56A9"/>
                 </a:solidFill>
                 <a:latin typeface="Inter"/>
               </a:rPr>
@@ -8700,7 +8700,7 @@
                 </a:solidFill>
                 <a:latin typeface="Inter"/>
               </a:rPr>
-              <a:t>U0 · ¡VOLVEMOS!   ·   C5 · A1 · La Ruta</a:t>
+              <a:t>U0 · ¡VOLVEMOS!   ·   C6+ · el reencuentro</a:t>
             </a:r>
           </a:p>
         </p:txBody>
@@ -9326,7 +9326,7 @@
             <a:avLst/>
           </a:prstGeom>
           <a:solidFill>
-            <a:srgbClr val="1E9E74"/>
+            <a:srgbClr val="7C56A9"/>
           </a:solidFill>
           <a:ln>
             <a:noFill/>
@@ -9445,7 +9445,7 @@
             <a:r>
               <a:rPr sz="1100" b="1">
                 <a:solidFill>
-                  <a:srgbClr val="1E9E74"/>
+                  <a:srgbClr val="7C56A9"/>
                 </a:solidFill>
                 <a:latin typeface="Inter"/>
               </a:rPr>
@@ -11046,7 +11046,7 @@
                 </a:solidFill>
                 <a:latin typeface="Inter"/>
               </a:rPr>
-              <a:t>U0 · ¡VOLVEMOS!   ·   C5 · A1 · La Ruta</a:t>
+              <a:t>U0 · ¡VOLVEMOS!   ·   C6+ · el reencuentro</a:t>
             </a:r>
           </a:p>
         </p:txBody>
@@ -11354,7 +11354,7 @@
             <a:avLst/>
           </a:prstGeom>
           <a:solidFill>
-            <a:srgbClr val="1E9E74"/>
+            <a:srgbClr val="7C56A9"/>
           </a:solidFill>
           <a:ln>
             <a:noFill/>
@@ -11473,7 +11473,7 @@
             <a:r>
               <a:rPr sz="1100" b="1">
                 <a:solidFill>
-                  <a:srgbClr val="1E9E74"/>
+                  <a:srgbClr val="7C56A9"/>
                 </a:solidFill>
                 <a:latin typeface="Inter"/>
               </a:rPr>
@@ -12716,7 +12716,7 @@
                 </a:solidFill>
                 <a:latin typeface="Inter"/>
               </a:rPr>
-              <a:t>U0 · ¡VOLVEMOS!   ·   C5 · A1 · La Ruta</a:t>
+              <a:t>U0 · ¡VOLVEMOS!   ·   C6+ · el reencuentro</a:t>
             </a:r>
           </a:p>
         </p:txBody>
@@ -12971,7 +12971,7 @@
             <a:avLst/>
           </a:prstGeom>
           <a:solidFill>
-            <a:srgbClr val="1E9E74"/>
+            <a:srgbClr val="7C56A9"/>
           </a:solidFill>
           <a:ln>
             <a:noFill/>
@@ -13090,7 +13090,7 @@
             <a:r>
               <a:rPr sz="1100" b="1">
                 <a:solidFill>
-                  <a:srgbClr val="1E9E74"/>
+                  <a:srgbClr val="7C56A9"/>
                 </a:solidFill>
                 <a:latin typeface="Inter"/>
               </a:rPr>
@@ -15363,7 +15363,7 @@
                 </a:solidFill>
                 <a:latin typeface="Inter"/>
               </a:rPr>
-              <a:t>U0 · ¡VOLVEMOS!   ·   C5 · A1 · La Ruta</a:t>
+              <a:t>U0 · ¡VOLVEMOS!   ·   C6+ · el reencuentro</a:t>
             </a:r>
           </a:p>
         </p:txBody>
@@ -16307,7 +16307,7 @@
             <a:avLst/>
           </a:prstGeom>
           <a:solidFill>
-            <a:srgbClr val="1E9E74"/>
+            <a:srgbClr val="7C56A9"/>
           </a:solidFill>
           <a:ln>
             <a:noFill/>
@@ -16426,7 +16426,7 @@
             <a:r>
               <a:rPr sz="1100" b="1">
                 <a:solidFill>
-                  <a:srgbClr val="1E9E74"/>
+                  <a:srgbClr val="7C56A9"/>
                 </a:solidFill>
                 <a:latin typeface="Inter"/>
               </a:rPr>
@@ -18237,7 +18237,7 @@
                 </a:solidFill>
                 <a:latin typeface="Inter"/>
               </a:rPr>
-              <a:t>U0 · ¡VOLVEMOS!   ·   C5 · A1 · La Ruta</a:t>
+              <a:t>U0 · ¡VOLVEMOS!   ·   C6+ · el reencuentro</a:t>
             </a:r>
           </a:p>
         </p:txBody>
@@ -18969,7 +18969,7 @@
             <a:avLst/>
           </a:prstGeom>
           <a:solidFill>
-            <a:srgbClr val="1E9E74"/>
+            <a:srgbClr val="7C56A9"/>
           </a:solidFill>
           <a:ln>
             <a:noFill/>
@@ -19088,7 +19088,7 @@
             <a:r>
               <a:rPr sz="1100" b="1">
                 <a:solidFill>
-                  <a:srgbClr val="1E9E74"/>
+                  <a:srgbClr val="7C56A9"/>
                 </a:solidFill>
                 <a:latin typeface="Inter"/>
               </a:rPr>
@@ -20376,7 +20376,7 @@
                 </a:solidFill>
                 <a:latin typeface="Inter"/>
               </a:rPr>
-              <a:t>U0 · ¡VOLVEMOS!   ·   C5 · A1 · La Ruta</a:t>
+              <a:t>U0 · ¡VOLVEMOS!   ·   C6+ · el reencuentro</a:t>
             </a:r>
           </a:p>
         </p:txBody>
@@ -20843,7 +20843,7 @@
             <a:avLst/>
           </a:prstGeom>
           <a:solidFill>
-            <a:srgbClr val="1E9E74"/>
+            <a:srgbClr val="7C56A9"/>
           </a:solidFill>
           <a:ln>
             <a:noFill/>
@@ -20962,7 +20962,7 @@
             <a:r>
               <a:rPr sz="1100" b="1">
                 <a:solidFill>
-                  <a:srgbClr val="1E9E74"/>
+                  <a:srgbClr val="7C56A9"/>
                 </a:solidFill>
                 <a:latin typeface="Inter"/>
               </a:rPr>
@@ -22376,7 +22376,7 @@
                 </a:solidFill>
                 <a:latin typeface="Inter"/>
               </a:rPr>
-              <a:t>U0 · ¡VOLVEMOS!   ·   C5 · A1 · La Ruta</a:t>
+              <a:t>U0 · ¡VOLVEMOS!   ·   C6+ · el reencuentro</a:t>
             </a:r>
           </a:p>
         </p:txBody>
@@ -24259,7 +24259,7 @@
                 </a:solidFill>
                 <a:latin typeface="Inter"/>
               </a:rPr>
-              <a:t>U0 · ¡VOLVEMOS!   ·   C5 · A1 · La Ruta</a:t>
+              <a:t>U0 · ¡VOLVEMOS!   ·   C6+ · el reencuentro</a:t>
             </a:r>
           </a:p>
         </p:txBody>
@@ -24431,7 +24431,7 @@
             <a:avLst/>
           </a:prstGeom>
           <a:solidFill>
-            <a:srgbClr val="1E9E74"/>
+            <a:srgbClr val="7C56A9"/>
           </a:solidFill>
           <a:ln>
             <a:noFill/>
@@ -24550,7 +24550,7 @@
             <a:r>
               <a:rPr sz="1100" b="1">
                 <a:solidFill>
-                  <a:srgbClr val="1E9E74"/>
+                  <a:srgbClr val="7C56A9"/>
                 </a:solidFill>
                 <a:latin typeface="Inter"/>
               </a:rPr>
@@ -26240,7 +26240,7 @@
                 </a:solidFill>
                 <a:latin typeface="Inter"/>
               </a:rPr>
-              <a:t>U0 · ¡VOLVEMOS!   ·   C5 · A1 · La Ruta</a:t>
+              <a:t>U0 · ¡VOLVEMOS!   ·   C6+ · el reencuentro</a:t>
             </a:r>
           </a:p>
         </p:txBody>
@@ -26972,7 +26972,7 @@
             <a:avLst/>
           </a:prstGeom>
           <a:solidFill>
-            <a:srgbClr val="1E9E74"/>
+            <a:srgbClr val="7C56A9"/>
           </a:solidFill>
           <a:ln>
             <a:noFill/>
@@ -27091,7 +27091,7 @@
             <a:r>
               <a:rPr sz="1100" b="1">
                 <a:solidFill>
-                  <a:srgbClr val="1E9E74"/>
+                  <a:srgbClr val="7C56A9"/>
                 </a:solidFill>
                 <a:latin typeface="Inter"/>
               </a:rPr>
@@ -29752,7 +29752,7 @@
                 </a:solidFill>
                 <a:latin typeface="Inter"/>
               </a:rPr>
-              <a:t>U0 · ¡VOLVEMOS!   ·   C5 · A1 · La Ruta</a:t>
+              <a:t>U0 · ¡VOLVEMOS!   ·   C6+ · el reencuentro</a:t>
             </a:r>
           </a:p>
         </p:txBody>
@@ -29924,7 +29924,7 @@
             <a:avLst/>
           </a:prstGeom>
           <a:solidFill>
-            <a:srgbClr val="1E9E74"/>
+            <a:srgbClr val="7C56A9"/>
           </a:solidFill>
           <a:ln>
             <a:noFill/>
@@ -30043,7 +30043,7 @@
             <a:r>
               <a:rPr sz="1100" b="1">
                 <a:solidFill>
-                  <a:srgbClr val="1E9E74"/>
+                  <a:srgbClr val="7C56A9"/>
                 </a:solidFill>
                 <a:latin typeface="Inter"/>
               </a:rPr>
@@ -31698,7 +31698,7 @@
                 </a:solidFill>
                 <a:latin typeface="Inter"/>
               </a:rPr>
-              <a:t>U0 · ¡VOLVEMOS!   ·   C5 · A1 · La Ruta</a:t>
+              <a:t>U0 · ¡VOLVEMOS!   ·   C6+ · el reencuentro</a:t>
             </a:r>
           </a:p>
         </p:txBody>
@@ -31870,7 +31870,7 @@
             <a:avLst/>
           </a:prstGeom>
           <a:solidFill>
-            <a:srgbClr val="1E9E74"/>
+            <a:srgbClr val="7C56A9"/>
           </a:solidFill>
           <a:ln>
             <a:noFill/>
@@ -31989,7 +31989,7 @@
             <a:r>
               <a:rPr sz="1100" b="1">
                 <a:solidFill>
-                  <a:srgbClr val="1E9E74"/>
+                  <a:srgbClr val="7C56A9"/>
                 </a:solidFill>
                 <a:latin typeface="Inter"/>
               </a:rPr>
@@ -32468,7 +32468,7 @@
             </a:avLst>
           </a:prstGeom>
           <a:solidFill>
-            <a:srgbClr val="14B8A6"/>
+            <a:srgbClr val="64748B"/>
           </a:solidFill>
           <a:ln>
             <a:noFill/>
@@ -34642,7 +34642,7 @@
                 </a:solidFill>
                 <a:latin typeface="Inter"/>
               </a:rPr>
-              <a:t>U0 · ¡VOLVEMOS!   ·   C5 · A1 · La Ruta</a:t>
+              <a:t>U0 · ¡VOLVEMOS!   ·   C6+ · el reencuentro</a:t>
             </a:r>
           </a:p>
         </p:txBody>
@@ -34950,7 +34950,7 @@
             <a:avLst/>
           </a:prstGeom>
           <a:solidFill>
-            <a:srgbClr val="1E9E74"/>
+            <a:srgbClr val="7C56A9"/>
           </a:solidFill>
           <a:ln>
             <a:noFill/>
@@ -35069,7 +35069,7 @@
             <a:r>
               <a:rPr sz="1100" b="1">
                 <a:solidFill>
-                  <a:srgbClr val="1E9E74"/>
+                  <a:srgbClr val="7C56A9"/>
                 </a:solidFill>
                 <a:latin typeface="Inter"/>
               </a:rPr>
@@ -35548,7 +35548,7 @@
             </a:avLst>
           </a:prstGeom>
           <a:solidFill>
-            <a:srgbClr val="14B8A6"/>
+            <a:srgbClr val="64748B"/>
           </a:solidFill>
           <a:ln>
             <a:noFill/>
@@ -35820,7 +35820,7 @@
             <a:r>
               <a:rPr sz="2200" b="1" i="0">
                 <a:solidFill>
-                  <a:srgbClr val="1E9E74"/>
+                  <a:srgbClr val="B4309A"/>
                 </a:solidFill>
                 <a:latin typeface="Bricolage Grotesque"/>
               </a:rPr>
@@ -35847,7 +35847,7 @@
             <a:r>
               <a:rPr sz="2200" b="1" i="0">
                 <a:solidFill>
-                  <a:srgbClr val="14B8A6"/>
+                  <a:srgbClr val="64748B"/>
                 </a:solidFill>
                 <a:latin typeface="Bricolage Grotesque"/>
               </a:rPr>
@@ -36779,7 +36779,7 @@
                 </a:solidFill>
                 <a:latin typeface="Inter"/>
               </a:rPr>
-              <a:t>U0 · ¡VOLVEMOS!   ·   C5 · A1 · La Ruta</a:t>
+              <a:t>U0 · ¡VOLVEMOS!   ·   C6+ · el reencuentro</a:t>
             </a:r>
           </a:p>
         </p:txBody>
@@ -37087,7 +37087,7 @@
             <a:avLst/>
           </a:prstGeom>
           <a:solidFill>
-            <a:srgbClr val="1E9E74"/>
+            <a:srgbClr val="7C56A9"/>
           </a:solidFill>
           <a:ln>
             <a:noFill/>
@@ -37206,7 +37206,7 @@
             <a:r>
               <a:rPr sz="1100" b="1">
                 <a:solidFill>
-                  <a:srgbClr val="1E9E74"/>
+                  <a:srgbClr val="7C56A9"/>
                 </a:solidFill>
                 <a:latin typeface="Inter"/>
               </a:rPr>
@@ -38620,7 +38620,7 @@
                 </a:solidFill>
                 <a:latin typeface="Inter"/>
               </a:rPr>
-              <a:t>U0 · ¡VOLVEMOS!   ·   C5 · A1 · La Ruta</a:t>
+              <a:t>U0 · ¡VOLVEMOS!   ·   C6+ · el reencuentro</a:t>
             </a:r>
           </a:p>
         </p:txBody>
@@ -39246,7 +39246,7 @@
             <a:avLst/>
           </a:prstGeom>
           <a:solidFill>
-            <a:srgbClr val="1E9E74"/>
+            <a:srgbClr val="7C56A9"/>
           </a:solidFill>
           <a:ln>
             <a:noFill/>
@@ -39365,7 +39365,7 @@
             <a:r>
               <a:rPr sz="1100" b="1">
                 <a:solidFill>
-                  <a:srgbClr val="1E9E74"/>
+                  <a:srgbClr val="7C56A9"/>
                 </a:solidFill>
                 <a:latin typeface="Inter"/>
               </a:rPr>
@@ -40442,7 +40442,7 @@
             <a:r>
               <a:rPr sz="1300" b="1" i="0">
                 <a:solidFill>
-                  <a:srgbClr val="14B8A6"/>
+                  <a:srgbClr val="64748B"/>
                 </a:solidFill>
                 <a:latin typeface="Inter"/>
               </a:rPr>
@@ -40902,7 +40902,7 @@
                 </a:solidFill>
                 <a:latin typeface="Inter"/>
               </a:rPr>
-              <a:t>U0 · ¡VOLVEMOS!   ·   C5 · A1 · La Ruta</a:t>
+              <a:t>U0 · ¡VOLVEMOS!   ·   C6+ · el reencuentro</a:t>
             </a:r>
           </a:p>
         </p:txBody>
@@ -41528,7 +41528,7 @@
             <a:avLst/>
           </a:prstGeom>
           <a:solidFill>
-            <a:srgbClr val="1E9E74"/>
+            <a:srgbClr val="7C56A9"/>
           </a:solidFill>
           <a:ln>
             <a:noFill/>
@@ -41647,7 +41647,7 @@
             <a:r>
               <a:rPr sz="1100" b="1">
                 <a:solidFill>
-                  <a:srgbClr val="1E9E74"/>
+                  <a:srgbClr val="7C56A9"/>
                 </a:solidFill>
                 <a:latin typeface="Inter"/>
               </a:rPr>
@@ -42126,7 +42126,7 @@
             </a:avLst>
           </a:prstGeom>
           <a:solidFill>
-            <a:srgbClr val="14B8A6"/>
+            <a:srgbClr val="64748B"/>
           </a:solidFill>
           <a:ln>
             <a:noFill/>
@@ -43829,7 +43829,7 @@
                 </a:solidFill>
                 <a:latin typeface="Inter"/>
               </a:rPr>
-              <a:t>U0 · ¡VOLVEMOS!   ·   C5 · A1 · La Ruta</a:t>
+              <a:t>U0 · ¡VOLVEMOS!   ·   C6+ · el reencuentro</a:t>
             </a:r>
           </a:p>
         </p:txBody>
@@ -44137,7 +44137,7 @@
             <a:avLst/>
           </a:prstGeom>
           <a:solidFill>
-            <a:srgbClr val="1E9E74"/>
+            <a:srgbClr val="7C56A9"/>
           </a:solidFill>
           <a:ln>
             <a:noFill/>
@@ -44256,7 +44256,7 @@
             <a:r>
               <a:rPr sz="1100" b="1">
                 <a:solidFill>
-                  <a:srgbClr val="1E9E74"/>
+                  <a:srgbClr val="7C56A9"/>
                 </a:solidFill>
                 <a:latin typeface="Inter"/>
               </a:rPr>
@@ -45670,7 +45670,7 @@
                 </a:solidFill>
                 <a:latin typeface="Inter"/>
               </a:rPr>
-              <a:t>U0 · ¡VOLVEMOS!   ·   C5 · A1 · La Ruta</a:t>
+              <a:t>U0 · ¡VOLVEMOS!   ·   C6+ · el reencuentro</a:t>
             </a:r>
           </a:p>
         </p:txBody>
@@ -46296,7 +46296,7 @@
             <a:avLst/>
           </a:prstGeom>
           <a:solidFill>
-            <a:srgbClr val="1E9E74"/>
+            <a:srgbClr val="7C56A9"/>
           </a:solidFill>
           <a:ln>
             <a:noFill/>
@@ -46415,7 +46415,7 @@
             <a:r>
               <a:rPr sz="1100" b="1">
                 <a:solidFill>
-                  <a:srgbClr val="1E9E74"/>
+                  <a:srgbClr val="7C56A9"/>
                 </a:solidFill>
                 <a:latin typeface="Inter"/>
               </a:rPr>
@@ -47746,7 +47746,7 @@
                 </a:solidFill>
                 <a:latin typeface="Inter"/>
               </a:rPr>
-              <a:t>U0 · ¡VOLVEMOS!   ·   C5 · A1 · La Ruta</a:t>
+              <a:t>U0 · ¡VOLVEMOS!   ·   C6+ · el reencuentro</a:t>
             </a:r>
           </a:p>
         </p:txBody>

</xml_diff>